<commit_message>
Set the INA219 to its 32 V range and read its bytes in order
The config word selected the 16 V range despite its "32V" comment, below a
charged 4S pack. And (Wire.read() << 8) | Wire.read() lets C++ call either
read first. Fixed in Op 12 and a5b, and on the Lesson 5 slide that quotes it.

Co-Authored-By: Claude Opus 5.5 <noreply@anthropic.com>
</commit_message>
<xml_diff>
--- a/ground-vehicle/docs/courses/advanced/l5_sensors_and_self_test.pptx
+++ b/ground-vehicle/docs/courses/advanced/l5_sensors_and_self_test.pptx
@@ -622,6 +622,14 @@
                 <a:latin typeface="Calibri"/>
               </a:rPr>
               <a:t>The repeated start matters: a full stop would let another master grab the bus between writing the register number and reading the answer.</a:t>
+            </a:r>
+          </a:p>
+          <a:p>
+            <a:r>
+              <a:rPr sz="1200">
+                <a:latin typeface="Calibri"/>
+              </a:rPr>
+              <a:t>The two reads are separate statements on purpose. Written as (Wire.read() &lt;&lt; 8) | Wire.read(), C++ does not promise which read() runs first - the bytes can come back swapped.</a:t>
             </a:r>
           </a:p>
           <a:p>
@@ -6304,7 +6312,73 @@
                 </a:solidFill>
                 <a:latin typeface="Consolas"/>
               </a:rPr>
-              <a:t>  return Wire.available() &gt;= 2 ? (Wire.read() &lt;&lt; 8) | Wire.read() : 0;</a:t>
+              <a:t>  if (Wire.available() &lt; 2) return 0;</a:t>
+            </a:r>
+          </a:p>
+          <a:p>
+            <a:pPr algn="l">
+              <a:lnSpc>
+                <a:spcPct val="100000"/>
+              </a:lnSpc>
+              <a:spcAft>
+                <a:spcPts val="0"/>
+              </a:spcAft>
+              <a:defRPr sz="1400">
+                <a:latin typeface="Consolas"/>
+              </a:defRPr>
+            </a:pPr>
+            <a:r>
+              <a:rPr sz="1400" b="1">
+                <a:solidFill>
+                  <a:srgbClr val="0E7C86"/>
+                </a:solidFill>
+                <a:latin typeface="Consolas"/>
+              </a:rPr>
+              <a:t>  uint8_t high = Wire.read();</a:t>
+            </a:r>
+          </a:p>
+          <a:p>
+            <a:pPr algn="l">
+              <a:lnSpc>
+                <a:spcPct val="100000"/>
+              </a:lnSpc>
+              <a:spcAft>
+                <a:spcPts val="0"/>
+              </a:spcAft>
+              <a:defRPr sz="1400">
+                <a:latin typeface="Consolas"/>
+              </a:defRPr>
+            </a:pPr>
+            <a:r>
+              <a:rPr sz="1400">
+                <a:solidFill>
+                  <a:srgbClr val="222222"/>
+                </a:solidFill>
+                <a:latin typeface="Consolas"/>
+              </a:rPr>
+              <a:t>  uint8_t low  = Wire.read();</a:t>
+            </a:r>
+          </a:p>
+          <a:p>
+            <a:pPr algn="l">
+              <a:lnSpc>
+                <a:spcPct val="100000"/>
+              </a:lnSpc>
+              <a:spcAft>
+                <a:spcPts val="0"/>
+              </a:spcAft>
+              <a:defRPr sz="1400">
+                <a:latin typeface="Consolas"/>
+              </a:defRPr>
+            </a:pPr>
+            <a:r>
+              <a:rPr sz="1400">
+                <a:solidFill>
+                  <a:srgbClr val="222222"/>
+                </a:solidFill>
+                <a:latin typeface="Consolas"/>
+              </a:rPr>
+              <a:t>  return (high &lt;&lt; 8) | low;</a:t>
             </a:r>
           </a:p>
           <a:p>
@@ -6580,15 +6654,15 @@
               <a:spcAft>
                 <a:spcPts val="700"/>
               </a:spcAft>
-              <a:defRPr sz="2100" b="0">
-                <a:solidFill>
-                  <a:srgbClr val="222222"/>
-                </a:solidFill>
-                <a:latin typeface="Calibri"/>
-              </a:defRPr>
-            </a:pPr>
-            <a:r>
-              <a:rPr sz="2100" b="0">
+              <a:defRPr sz="1800" b="0">
+                <a:solidFill>
+                  <a:srgbClr val="222222"/>
+                </a:solidFill>
+                <a:latin typeface="Calibri"/>
+              </a:defRPr>
+            </a:pPr>
+            <a:r>
+              <a:rPr sz="1800" b="0">
                 <a:solidFill>
                   <a:srgbClr val="222222"/>
                 </a:solidFill>
@@ -6605,15 +6679,40 @@
               <a:spcAft>
                 <a:spcPts val="700"/>
               </a:spcAft>
-              <a:defRPr sz="2100" b="0">
-                <a:solidFill>
-                  <a:srgbClr val="222222"/>
-                </a:solidFill>
-                <a:latin typeface="Calibri"/>
-              </a:defRPr>
-            </a:pPr>
-            <a:r>
-              <a:rPr sz="2100" b="0">
+              <a:defRPr sz="1800" b="0">
+                <a:solidFill>
+                  <a:srgbClr val="222222"/>
+                </a:solidFill>
+                <a:latin typeface="Calibri"/>
+              </a:defRPr>
+            </a:pPr>
+            <a:r>
+              <a:rPr sz="1800" b="0">
+                <a:solidFill>
+                  <a:srgbClr val="222222"/>
+                </a:solidFill>
+                <a:latin typeface="Calibri"/>
+              </a:rPr>
+              <a:t>High byte, then low byte, as two statements. In one expression C++ may call either read() first.</a:t>
+            </a:r>
+          </a:p>
+          <a:p>
+            <a:pPr algn="l">
+              <a:lnSpc>
+                <a:spcPct val="100000"/>
+              </a:lnSpc>
+              <a:spcAft>
+                <a:spcPts val="700"/>
+              </a:spcAft>
+              <a:defRPr sz="1800" b="0">
+                <a:solidFill>
+                  <a:srgbClr val="222222"/>
+                </a:solidFill>
+                <a:latin typeface="Calibri"/>
+              </a:defRPr>
+            </a:pPr>
+            <a:r>
+              <a:rPr sz="1800" b="0">
                 <a:solidFill>
                   <a:srgbClr val="222222"/>
                 </a:solidFill>
@@ -6630,15 +6729,15 @@
               <a:spcAft>
                 <a:spcPts val="700"/>
               </a:spcAft>
-              <a:defRPr sz="2100" b="0">
-                <a:solidFill>
-                  <a:srgbClr val="222222"/>
-                </a:solidFill>
-                <a:latin typeface="Calibri"/>
-              </a:defRPr>
-            </a:pPr>
-            <a:r>
-              <a:rPr sz="2100" b="0">
+              <a:defRPr sz="1800" b="0">
+                <a:solidFill>
+                  <a:srgbClr val="222222"/>
+                </a:solidFill>
+                <a:latin typeface="Calibri"/>
+              </a:defRPr>
+            </a:pPr>
+            <a:r>
+              <a:rPr sz="1800" b="0">
                 <a:solidFill>
                   <a:srgbClr val="222222"/>
                 </a:solidFill>
@@ -6655,15 +6754,15 @@
               <a:spcAft>
                 <a:spcPts val="700"/>
               </a:spcAft>
-              <a:defRPr sz="2100" b="0">
-                <a:solidFill>
-                  <a:srgbClr val="222222"/>
-                </a:solidFill>
-                <a:latin typeface="Calibri"/>
-              </a:defRPr>
-            </a:pPr>
-            <a:r>
-              <a:rPr sz="2100" b="0">
+              <a:defRPr sz="1800" b="0">
+                <a:solidFill>
+                  <a:srgbClr val="222222"/>
+                </a:solidFill>
+                <a:latin typeface="Calibri"/>
+              </a:defRPr>
+            </a:pPr>
+            <a:r>
+              <a:rPr sz="1800" b="0">
                 <a:solidFill>
                   <a:srgbClr val="222222"/>
                 </a:solidFill>

</xml_diff>